<commit_message>
Simplify powers lesson plan, add printable activity cards, rename exit card to assessment card
Co-Authored-By: Claude Opus 5.5 <noreply@anthropic.com>
Claude-Session: https://claude.ai/code/session_017JUyyiwxAfDv5ntrydzjix
</commit_message>
<xml_diff>
--- a/lesson-plans/عرض-درس-القوى.pptx
+++ b/lesson-plans/عرض-درس-القوى.pptx
@@ -123,19 +123,19 @@
   <p:extLst>
     <p:ext uri="{521415D9-36F7-43E2-AB2F-B90AF26B5E84}">
       <p14:sectionLst xmlns:p14="http://schemas.microsoft.com/office/powerpoint/2010/main">
-        <p14:section name="البداية" id="{188a294e-be67-560b-2951-a49288088c01}">
+        <p14:section name="البداية" id="{ffb1c5d5-bc88-dcff-6ab7-18e28199c838}">
           <p14:sldIdLst>
             <p14:sldId id="256"/>
             <p14:sldId id="257"/>
           </p14:sldIdLst>
         </p14:section>
-        <p14:section name="التمهيد" id="{ebd9c3a4-0bc0-3b9c-d07b-3d7e948d4fdb}">
+        <p14:section name="التمهيد" id="{2edea5d0-0dce-ab3f-268e-86e1c9fc20f8}">
           <p14:sldIdLst>
             <p14:sldId id="258"/>
             <p14:sldId id="259"/>
           </p14:sldIdLst>
         </p14:section>
-        <p14:section name="الاستكشاف" id="{4666168c-653f-2be4-224b-68fc2c1776ff}">
+        <p14:section name="الاستكشاف" id="{1d406267-0c9d-1d1c-3e8c-58cb9561e771}">
           <p14:sldIdLst>
             <p14:sldId id="260"/>
             <p14:sldId id="261"/>
@@ -144,7 +144,7 @@
             <p14:sldId id="264"/>
           </p14:sldIdLst>
         </p14:section>
-        <p14:section name="التطبيق التمايزي" id="{7f302da9-a4fb-ca21-c11b-da7a9d322539}">
+        <p14:section name="التطبيق التمايزي" id="{99b5ab6b-ce23-b05c-a85e-e3fc84a15212}">
           <p14:sldIdLst>
             <p14:sldId id="265"/>
             <p14:sldId id="266"/>
@@ -152,14 +152,14 @@
             <p14:sldId id="268"/>
           </p14:sldIdLst>
         </p14:section>
-        <p14:section name="التقييم" id="{5d6abf74-a060-7930-72b2-cbc3a1e7efdf}">
+        <p14:section name="التقييم" id="{613e26d8-a590-c43a-e833-47441852ee1f}">
           <p14:sldIdLst>
             <p14:sldId id="269"/>
             <p14:sldId id="270"/>
             <p14:sldId id="271"/>
           </p14:sldIdLst>
         </p14:section>
-        <p14:section name="الخلاصة" id="{f7bc2589-8cf0-e874-1327-ff5a426841b0}">
+        <p14:section name="الخلاصة" id="{b599fbf2-f271-d8b3-235e-74b7bf259cb1}">
           <p14:sldIdLst>
             <p14:sldId id="272"/>
           </p14:sldIdLst>
@@ -5840,7 +5840,7 @@
                   <a:schemeClr val="tx2"/>
                 </a:solidFill>
               </a:rPr>
-              <a:t>بطاقة الخروج</a:t>
+              <a:t>بطاقة التقييم</a:t>
             </a:r>
             <a:endParaRPr lang="en-US" sz="3000" dirty="0"/>
           </a:p>
@@ -7226,7 +7226,7 @@
                   <a:schemeClr val="tx2"/>
                 </a:solidFill>
               </a:rPr>
-              <a:t>حلول بطاقة الخروج</a:t>
+              <a:t>حلول بطاقة التقييم</a:t>
             </a:r>
             <a:endParaRPr lang="en-US" sz="3000" dirty="0"/>
           </a:p>
@@ -8254,7 +8254,7 @@
         </p:nvSpPr>
         <p:spPr>
           <a:xfrm>
-            <a:off x="548640" y="1234440"/>
+            <a:off x="548640" y="1371600"/>
             <a:ext cx="7680960" cy="658368"/>
           </a:xfrm>
           <a:prstGeom prst="roundRect">
@@ -8283,7 +8283,7 @@
         </p:nvSpPr>
         <p:spPr>
           <a:xfrm>
-            <a:off x="8366760" y="1307592"/>
+            <a:off x="8366760" y="1444752"/>
             <a:ext cx="502920" cy="502920"/>
           </a:xfrm>
           <a:prstGeom prst="ellipse">
@@ -8303,7 +8303,7 @@
         </p:nvSpPr>
         <p:spPr>
           <a:xfrm>
-            <a:off x="8366760" y="1307592"/>
+            <a:off x="8366760" y="1444752"/>
             <a:ext cx="502920" cy="502920"/>
           </a:xfrm>
           <a:prstGeom prst="rect">
@@ -8339,7 +8339,7 @@
         </p:nvSpPr>
         <p:spPr>
           <a:xfrm>
-            <a:off x="731520" y="1234440"/>
+            <a:off x="731520" y="1371600"/>
             <a:ext cx="7406640" cy="658368"/>
           </a:xfrm>
           <a:prstGeom prst="rect">
@@ -8361,7 +8361,7 @@
                   <a:schemeClr val="tx1"/>
                 </a:solidFill>
               </a:rPr>
-              <a:t>أكتب جداء عوامل متساوية على شكل قوة ‪aⁿ‬</a:t>
+              <a:t>أكتب جداء عوامل متساوية على شكل قوة</a:t>
             </a:r>
             <a:endParaRPr lang="ar-SA" sz="2000" dirty="0"/>
           </a:p>
@@ -8375,7 +8375,7 @@
         </p:nvSpPr>
         <p:spPr>
           <a:xfrm>
-            <a:off x="548640" y="2057400"/>
+            <a:off x="548640" y="2331720"/>
             <a:ext cx="7680960" cy="658368"/>
           </a:xfrm>
           <a:prstGeom prst="roundRect">
@@ -8404,7 +8404,7 @@
         </p:nvSpPr>
         <p:spPr>
           <a:xfrm>
-            <a:off x="8366760" y="2130552"/>
+            <a:off x="8366760" y="2404872"/>
             <a:ext cx="502920" cy="502920"/>
           </a:xfrm>
           <a:prstGeom prst="ellipse">
@@ -8424,7 +8424,7 @@
         </p:nvSpPr>
         <p:spPr>
           <a:xfrm>
-            <a:off x="8366760" y="2130552"/>
+            <a:off x="8366760" y="2404872"/>
             <a:ext cx="502920" cy="502920"/>
           </a:xfrm>
           <a:prstGeom prst="rect">
@@ -8460,7 +8460,7 @@
         </p:nvSpPr>
         <p:spPr>
           <a:xfrm>
-            <a:off x="731520" y="2057400"/>
+            <a:off x="731520" y="2331720"/>
             <a:ext cx="7406640" cy="658368"/>
           </a:xfrm>
           <a:prstGeom prst="rect">
@@ -8482,7 +8482,7 @@
                   <a:schemeClr val="tx1"/>
                 </a:solidFill>
               </a:rPr>
-              <a:t>أحدّد الأساس والأس في قوة وأقرؤها قراءة صحيحة</a:t>
+              <a:t>أحدّد الأساس والأس في قوة معطاة</a:t>
             </a:r>
             <a:endParaRPr lang="ar-SA" sz="2000" dirty="0"/>
           </a:p>
@@ -8496,7 +8496,7 @@
         </p:nvSpPr>
         <p:spPr>
           <a:xfrm>
-            <a:off x="548640" y="2880360"/>
+            <a:off x="548640" y="3291840"/>
             <a:ext cx="7680960" cy="658368"/>
           </a:xfrm>
           <a:prstGeom prst="roundRect">
@@ -8525,7 +8525,7 @@
         </p:nvSpPr>
         <p:spPr>
           <a:xfrm>
-            <a:off x="8366760" y="2953512"/>
+            <a:off x="8366760" y="3364992"/>
             <a:ext cx="502920" cy="502920"/>
           </a:xfrm>
           <a:prstGeom prst="ellipse">
@@ -8545,7 +8545,7 @@
         </p:nvSpPr>
         <p:spPr>
           <a:xfrm>
-            <a:off x="8366760" y="2953512"/>
+            <a:off x="8366760" y="3364992"/>
             <a:ext cx="502920" cy="502920"/>
           </a:xfrm>
           <a:prstGeom prst="rect">
@@ -8581,7 +8581,7 @@
         </p:nvSpPr>
         <p:spPr>
           <a:xfrm>
-            <a:off x="731520" y="2880360"/>
+            <a:off x="731520" y="3291840"/>
             <a:ext cx="7406640" cy="658368"/>
           </a:xfrm>
           <a:prstGeom prst="rect">
@@ -8603,128 +8603,7 @@
                   <a:schemeClr val="tx1"/>
                 </a:solidFill>
               </a:rPr>
-              <a:t>أحسب قيمة قوة: مربّع العدد ومكعّبه</a:t>
-            </a:r>
-            <a:endParaRPr lang="ar-SA" sz="2000" dirty="0"/>
-          </a:p>
-        </p:txBody>
-      </p:sp>
-      <p:sp>
-        <p:nvSpPr>
-          <p:cNvPr id="15" name="Shape 13"/>
-          <p:cNvSpPr/>
-          <p:nvPr/>
-        </p:nvSpPr>
-        <p:spPr>
-          <a:xfrm>
-            <a:off x="548640" y="3703320"/>
-            <a:ext cx="7680960" cy="658368"/>
-          </a:xfrm>
-          <a:prstGeom prst="roundRect">
-            <a:avLst>
-              <a:gd name="adj" fmla="val 16667"/>
-            </a:avLst>
-          </a:prstGeom>
-          <a:solidFill>
-            <a:schemeClr val="bg2"/>
-          </a:solidFill>
-          <a:ln/>
-          <a:effectLst>
-            <a:outerShdw sx="100000" sy="100000" kx="0" ky="0" algn="bl" rotWithShape="0" blurRad="76200" dist="25400" dir="5400000">
-              <a:srgbClr val="000000">
-                <a:alpha val="12000"/>
-              </a:srgbClr>
-            </a:outerShdw>
-          </a:effectLst>
-        </p:spPr>
-      </p:sp>
-      <p:sp>
-        <p:nvSpPr>
-          <p:cNvPr id="16" name="Shape 14"/>
-          <p:cNvSpPr/>
-          <p:nvPr/>
-        </p:nvSpPr>
-        <p:spPr>
-          <a:xfrm>
-            <a:off x="8366760" y="3776472"/>
-            <a:ext cx="502920" cy="502920"/>
-          </a:xfrm>
-          <a:prstGeom prst="ellipse">
-            <a:avLst/>
-          </a:prstGeom>
-          <a:solidFill>
-            <a:schemeClr val="tx2"/>
-          </a:solidFill>
-          <a:ln/>
-        </p:spPr>
-      </p:sp>
-      <p:sp>
-        <p:nvSpPr>
-          <p:cNvPr id="17" name="Text 15"/>
-          <p:cNvSpPr txBox="1"/>
-          <p:nvPr/>
-        </p:nvSpPr>
-        <p:spPr>
-          <a:xfrm>
-            <a:off x="8366760" y="3776472"/>
-            <a:ext cx="502920" cy="502920"/>
-          </a:xfrm>
-          <a:prstGeom prst="rect">
-            <a:avLst/>
-          </a:prstGeom>
-          <a:noFill/>
-          <a:ln/>
-        </p:spPr>
-        <p:txBody>
-          <a:bodyPr wrap="square" lIns="0" tIns="0" rIns="0" bIns="0" rtlCol="0" anchor="ctr"/>
-          <a:lstStyle/>
-          <a:p>
-            <a:pPr algn="ctr" indent="0" marL="0">
-              <a:buNone/>
-            </a:pPr>
-            <a:r>
-              <a:rPr lang="en-US" sz="1800" b="1" dirty="0">
-                <a:solidFill>
-                  <a:schemeClr val="bg1"/>
-                </a:solidFill>
-              </a:rPr>
-              <a:t>4</a:t>
-            </a:r>
-            <a:endParaRPr lang="en-US" sz="1800" dirty="0"/>
-          </a:p>
-        </p:txBody>
-      </p:sp>
-      <p:sp>
-        <p:nvSpPr>
-          <p:cNvPr id="18" name="Text 16"/>
-          <p:cNvSpPr txBox="1"/>
-          <p:nvPr/>
-        </p:nvSpPr>
-        <p:spPr>
-          <a:xfrm>
-            <a:off x="731520" y="3703320"/>
-            <a:ext cx="7406640" cy="658368"/>
-          </a:xfrm>
-          <a:prstGeom prst="rect">
-            <a:avLst/>
-          </a:prstGeom>
-          <a:noFill/>
-          <a:ln/>
-        </p:spPr>
-        <p:txBody>
-          <a:bodyPr wrap="square" rtlCol="0" anchor="ctr"/>
-          <a:lstStyle/>
-          <a:p>
-            <a:pPr rtl="1" algn="r" indent="0" marL="0">
-              <a:buNone/>
-            </a:pPr>
-            <a:r>
-              <a:rPr lang="ar-SA" altLang="en-US" sz="2000" dirty="0">
-                <a:solidFill>
-                  <a:schemeClr val="tx1"/>
-                </a:solidFill>
-              </a:rPr>
-              <a:t>أميّز بين القوة ‪2³‬ والجداء ‪2×3‬</a:t>
+              <a:t>أحسب قيمة قوة بسيطة</a:t>
             </a:r>
             <a:endParaRPr lang="ar-SA" sz="2000" dirty="0"/>
           </a:p>

</xml_diff>